<commit_message>
Fill assignment gaps in docs, charts, and Q&A coverage.
Add case study/solution-guide deliverables, embed charts in PPT/HTML, and complete missing analysis items.
</commit_message>
<xml_diff>
--- a/presentations/EDA02_hotel_harmony.pptx
+++ b/presentations/EDA02_hotel_harmony.pptx
@@ -14,6 +14,8 @@
     <p:sldId id="262" r:id="rId13"/>
     <p:sldId id="263" r:id="rId14"/>
     <p:sldId id="264" r:id="rId15"/>
+    <p:sldId id="265" r:id="rId16"/>
+    <p:sldId id="266" r:id="rId17"/>
   </p:sldIdLst>
   <p:sldSz cx="12191695" cy="6858000" type="screen4x3"/>
   <p:notesSz cx="6858000" cy="9144000"/>
@@ -3378,6 +3380,424 @@
 </p:sld>
 </file>
 
+<file path=ppt/slides/slide10.xml><?xml version="1.0" encoding="utf-8"?>
+<p:sld xmlns:a="http://schemas.openxmlformats.org/drawingml/2006/main" xmlns:p="http://schemas.openxmlformats.org/presentationml/2006/main" xmlns:r="http://schemas.openxmlformats.org/officeDocument/2006/relationships">
+  <p:cSld>
+    <p:spTree>
+      <p:nvGrpSpPr>
+        <p:cNvPr id="1" name=""/>
+        <p:cNvGrpSpPr/>
+        <p:nvPr/>
+      </p:nvGrpSpPr>
+      <p:grpSpPr/>
+      <p:sp>
+        <p:nvSpPr>
+          <p:cNvPr id="2" name="Rectangle 1"/>
+          <p:cNvSpPr/>
+          <p:nvPr/>
+        </p:nvSpPr>
+        <p:spPr>
+          <a:xfrm>
+            <a:off x="0" y="0"/>
+            <a:ext cx="12191695" cy="164592"/>
+          </a:xfrm>
+          <a:prstGeom prst="rect">
+            <a:avLst/>
+          </a:prstGeom>
+          <a:solidFill>
+            <a:srgbClr val="0E7490"/>
+          </a:solidFill>
+          <a:ln>
+            <a:noFill/>
+          </a:ln>
+        </p:spPr>
+        <p:style>
+          <a:lnRef idx="1">
+            <a:schemeClr val="accent1"/>
+          </a:lnRef>
+          <a:fillRef idx="3">
+            <a:schemeClr val="accent1"/>
+          </a:fillRef>
+          <a:effectRef idx="2">
+            <a:schemeClr val="accent1"/>
+          </a:effectRef>
+          <a:fontRef idx="minor">
+            <a:schemeClr val="lt1"/>
+          </a:fontRef>
+        </p:style>
+        <p:txBody>
+          <a:bodyPr rtlCol="0" anchor="ctr"/>
+          <a:lstStyle/>
+          <a:p>
+            <a:pPr algn="ctr"/>
+          </a:p>
+        </p:txBody>
+      </p:sp>
+      <p:sp>
+        <p:nvSpPr>
+          <p:cNvPr id="3" name="Rectangle 2"/>
+          <p:cNvSpPr/>
+          <p:nvPr/>
+        </p:nvSpPr>
+        <p:spPr>
+          <a:xfrm>
+            <a:off x="0" y="6473952"/>
+            <a:ext cx="12191695" cy="384048"/>
+          </a:xfrm>
+          <a:prstGeom prst="rect">
+            <a:avLst/>
+          </a:prstGeom>
+          <a:solidFill>
+            <a:srgbClr val="0F172A"/>
+          </a:solidFill>
+          <a:ln>
+            <a:noFill/>
+          </a:ln>
+        </p:spPr>
+        <p:style>
+          <a:lnRef idx="1">
+            <a:schemeClr val="accent1"/>
+          </a:lnRef>
+          <a:fillRef idx="3">
+            <a:schemeClr val="accent1"/>
+          </a:fillRef>
+          <a:effectRef idx="2">
+            <a:schemeClr val="accent1"/>
+          </a:effectRef>
+          <a:fontRef idx="minor">
+            <a:schemeClr val="lt1"/>
+          </a:fontRef>
+        </p:style>
+        <p:txBody>
+          <a:bodyPr rtlCol="0" anchor="ctr"/>
+          <a:lstStyle/>
+          <a:p>
+            <a:pPr algn="ctr"/>
+          </a:p>
+        </p:txBody>
+      </p:sp>
+      <p:sp>
+        <p:nvSpPr>
+          <p:cNvPr id="4" name="TextBox 3"/>
+          <p:cNvSpPr txBox="1"/>
+          <p:nvPr/>
+        </p:nvSpPr>
+        <p:spPr>
+          <a:xfrm>
+            <a:off x="502920" y="320040"/>
+            <a:ext cx="11155680" cy="640080"/>
+          </a:xfrm>
+          <a:prstGeom prst="rect">
+            <a:avLst/>
+          </a:prstGeom>
+          <a:noFill/>
+        </p:spPr>
+        <p:txBody>
+          <a:bodyPr wrap="none">
+            <a:spAutoFit/>
+          </a:bodyPr>
+          <a:lstStyle/>
+          <a:p>
+            <a:r>
+              <a:rPr sz="2800" b="1">
+                <a:solidFill>
+                  <a:srgbClr val="0F172A"/>
+                </a:solidFill>
+                <a:latin typeface="Calibri"/>
+              </a:rPr>
+              <a:t>7) Conclusion</a:t>
+            </a:r>
+          </a:p>
+        </p:txBody>
+      </p:sp>
+      <p:sp>
+        <p:nvSpPr>
+          <p:cNvPr id="5" name="TextBox 4"/>
+          <p:cNvSpPr txBox="1"/>
+          <p:nvPr/>
+        </p:nvSpPr>
+        <p:spPr>
+          <a:xfrm>
+            <a:off x="640080" y="1051560"/>
+            <a:ext cx="10972800" cy="4937760"/>
+          </a:xfrm>
+          <a:prstGeom prst="rect">
+            <a:avLst/>
+          </a:prstGeom>
+          <a:noFill/>
+        </p:spPr>
+        <p:txBody>
+          <a:bodyPr wrap="square">
+            <a:spAutoFit/>
+          </a:bodyPr>
+          <a:lstStyle/>
+          <a:p>
+            <a:pPr>
+              <a:spcAft>
+                <a:spcPts val="1000"/>
+              </a:spcAft>
+            </a:pPr>
+            <a:r>
+              <a:rPr sz="1800" b="0">
+                <a:solidFill>
+                  <a:srgbClr val="334155"/>
+                </a:solidFill>
+                <a:latin typeface="Calibri"/>
+              </a:rPr>
+              <a:t>•  Demand is seasonal and channel-dependent. City vs resort mix, non-refundable deposits, and long lead times are the practical levers for cancellation control, while ADR and segment mix drive revenue planning.</a:t>
+            </a:r>
+          </a:p>
+        </p:txBody>
+      </p:sp>
+    </p:spTree>
+  </p:cSld>
+  <p:clrMapOvr>
+    <a:masterClrMapping/>
+  </p:clrMapOvr>
+</p:sld>
+</file>
+
+<file path=ppt/slides/slide11.xml><?xml version="1.0" encoding="utf-8"?>
+<p:sld xmlns:a="http://schemas.openxmlformats.org/drawingml/2006/main" xmlns:p="http://schemas.openxmlformats.org/presentationml/2006/main" xmlns:r="http://schemas.openxmlformats.org/officeDocument/2006/relationships">
+  <p:cSld>
+    <p:spTree>
+      <p:nvGrpSpPr>
+        <p:cNvPr id="1" name=""/>
+        <p:cNvGrpSpPr/>
+        <p:nvPr/>
+      </p:nvGrpSpPr>
+      <p:grpSpPr/>
+      <p:sp>
+        <p:nvSpPr>
+          <p:cNvPr id="2" name="Rectangle 1"/>
+          <p:cNvSpPr/>
+          <p:nvPr/>
+        </p:nvSpPr>
+        <p:spPr>
+          <a:xfrm>
+            <a:off x="0" y="0"/>
+            <a:ext cx="12191695" cy="164592"/>
+          </a:xfrm>
+          <a:prstGeom prst="rect">
+            <a:avLst/>
+          </a:prstGeom>
+          <a:solidFill>
+            <a:srgbClr val="0E7490"/>
+          </a:solidFill>
+          <a:ln>
+            <a:noFill/>
+          </a:ln>
+        </p:spPr>
+        <p:style>
+          <a:lnRef idx="1">
+            <a:schemeClr val="accent1"/>
+          </a:lnRef>
+          <a:fillRef idx="3">
+            <a:schemeClr val="accent1"/>
+          </a:fillRef>
+          <a:effectRef idx="2">
+            <a:schemeClr val="accent1"/>
+          </a:effectRef>
+          <a:fontRef idx="minor">
+            <a:schemeClr val="lt1"/>
+          </a:fontRef>
+        </p:style>
+        <p:txBody>
+          <a:bodyPr rtlCol="0" anchor="ctr"/>
+          <a:lstStyle/>
+          <a:p>
+            <a:pPr algn="ctr"/>
+          </a:p>
+        </p:txBody>
+      </p:sp>
+      <p:sp>
+        <p:nvSpPr>
+          <p:cNvPr id="3" name="Rectangle 2"/>
+          <p:cNvSpPr/>
+          <p:nvPr/>
+        </p:nvSpPr>
+        <p:spPr>
+          <a:xfrm>
+            <a:off x="0" y="6473952"/>
+            <a:ext cx="12191695" cy="384048"/>
+          </a:xfrm>
+          <a:prstGeom prst="rect">
+            <a:avLst/>
+          </a:prstGeom>
+          <a:solidFill>
+            <a:srgbClr val="0F172A"/>
+          </a:solidFill>
+          <a:ln>
+            <a:noFill/>
+          </a:ln>
+        </p:spPr>
+        <p:style>
+          <a:lnRef idx="1">
+            <a:schemeClr val="accent1"/>
+          </a:lnRef>
+          <a:fillRef idx="3">
+            <a:schemeClr val="accent1"/>
+          </a:fillRef>
+          <a:effectRef idx="2">
+            <a:schemeClr val="accent1"/>
+          </a:effectRef>
+          <a:fontRef idx="minor">
+            <a:schemeClr val="lt1"/>
+          </a:fontRef>
+        </p:style>
+        <p:txBody>
+          <a:bodyPr rtlCol="0" anchor="ctr"/>
+          <a:lstStyle/>
+          <a:p>
+            <a:pPr algn="ctr"/>
+          </a:p>
+        </p:txBody>
+      </p:sp>
+      <p:sp>
+        <p:nvSpPr>
+          <p:cNvPr id="4" name="TextBox 3"/>
+          <p:cNvSpPr txBox="1"/>
+          <p:nvPr/>
+        </p:nvSpPr>
+        <p:spPr>
+          <a:xfrm>
+            <a:off x="502920" y="320040"/>
+            <a:ext cx="11155680" cy="640080"/>
+          </a:xfrm>
+          <a:prstGeom prst="rect">
+            <a:avLst/>
+          </a:prstGeom>
+          <a:noFill/>
+        </p:spPr>
+        <p:txBody>
+          <a:bodyPr wrap="none">
+            <a:spAutoFit/>
+          </a:bodyPr>
+          <a:lstStyle/>
+          <a:p>
+            <a:r>
+              <a:rPr sz="2800" b="1">
+                <a:solidFill>
+                  <a:srgbClr val="0F172A"/>
+                </a:solidFill>
+                <a:latin typeface="Calibri"/>
+              </a:rPr>
+              <a:t>8) Recommendations</a:t>
+            </a:r>
+          </a:p>
+        </p:txBody>
+      </p:sp>
+      <p:sp>
+        <p:nvSpPr>
+          <p:cNvPr id="5" name="TextBox 4"/>
+          <p:cNvSpPr txBox="1"/>
+          <p:nvPr/>
+        </p:nvSpPr>
+        <p:spPr>
+          <a:xfrm>
+            <a:off x="640080" y="1051560"/>
+            <a:ext cx="10972800" cy="4937760"/>
+          </a:xfrm>
+          <a:prstGeom prst="rect">
+            <a:avLst/>
+          </a:prstGeom>
+          <a:noFill/>
+        </p:spPr>
+        <p:txBody>
+          <a:bodyPr wrap="square">
+            <a:spAutoFit/>
+          </a:bodyPr>
+          <a:lstStyle/>
+          <a:p>
+            <a:pPr>
+              <a:spcAft>
+                <a:spcPts val="1000"/>
+              </a:spcAft>
+            </a:pPr>
+            <a:r>
+              <a:rPr sz="1800" b="0">
+                <a:solidFill>
+                  <a:srgbClr val="334155"/>
+                </a:solidFill>
+                <a:latin typeface="Calibri"/>
+              </a:rPr>
+              <a:t>•  Tighten deposit or reminder policies on long-lead leisure bookings with high cancel risk.</a:t>
+            </a:r>
+          </a:p>
+          <a:p>
+            <a:pPr>
+              <a:spcAft>
+                <a:spcPts val="1000"/>
+              </a:spcAft>
+            </a:pPr>
+            <a:r>
+              <a:rPr sz="1800" b="0">
+                <a:solidFill>
+                  <a:srgbClr val="334155"/>
+                </a:solidFill>
+                <a:latin typeface="Calibri"/>
+              </a:rPr>
+              <a:t>•  Staff and price for the summer/peak-month wave rather than a flat annual plan.</a:t>
+            </a:r>
+          </a:p>
+          <a:p>
+            <a:pPr>
+              <a:spcAft>
+                <a:spcPts val="1000"/>
+              </a:spcAft>
+            </a:pPr>
+            <a:r>
+              <a:rPr sz="1800" b="0">
+                <a:solidFill>
+                  <a:srgbClr val="334155"/>
+                </a:solidFill>
+                <a:latin typeface="Calibri"/>
+              </a:rPr>
+              <a:t>•  Protect relationships with TA/TO and Direct channels that carry volume.</a:t>
+            </a:r>
+          </a:p>
+          <a:p>
+            <a:pPr>
+              <a:spcAft>
+                <a:spcPts val="1000"/>
+              </a:spcAft>
+            </a:pPr>
+            <a:r>
+              <a:rPr sz="1800" b="0">
+                <a:solidFill>
+                  <a:srgbClr val="334155"/>
+                </a:solidFill>
+                <a:latin typeface="Calibri"/>
+              </a:rPr>
+              <a:t>•  Use parking and special-request data to design upsell packages, not only room rate.</a:t>
+            </a:r>
+          </a:p>
+          <a:p>
+            <a:pPr>
+              <a:spcAft>
+                <a:spcPts val="1000"/>
+              </a:spcAft>
+            </a:pPr>
+            <a:r>
+              <a:rPr sz="1800" b="0">
+                <a:solidFill>
+                  <a:srgbClr val="334155"/>
+                </a:solidFill>
+                <a:latin typeface="Calibri"/>
+              </a:rPr>
+              <a:t>•  Build a repeat-guest offer; loyalty stays look different from first-time transient stays.</a:t>
+            </a:r>
+          </a:p>
+        </p:txBody>
+      </p:sp>
+    </p:spTree>
+  </p:cSld>
+  <p:clrMapOvr>
+    <a:masterClrMapping/>
+  </p:clrMapOvr>
+</p:sld>
+</file>
+
 <file path=ppt/slides/slide2.xml><?xml version="1.0" encoding="utf-8"?>
 <p:sld xmlns:a="http://schemas.openxmlformats.org/drawingml/2006/main" xmlns:p="http://schemas.openxmlformats.org/presentationml/2006/main" xmlns:r="http://schemas.openxmlformats.org/officeDocument/2006/relationships">
   <p:cSld>
@@ -4236,6 +4656,54 @@
               <a:t>•  years: [2015, 2016, 2017]</a:t>
             </a:r>
           </a:p>
+          <a:p>
+            <a:pPr>
+              <a:spcAft>
+                <a:spcPts val="1000"/>
+              </a:spcAft>
+            </a:pPr>
+            <a:r>
+              <a:rPr sz="1800" b="0">
+                <a:solidFill>
+                  <a:srgbClr val="334155"/>
+                </a:solidFill>
+                <a:latin typeface="Calibri"/>
+              </a:rPr>
+              <a:t>•  average_stay_nights: 3.63</a:t>
+            </a:r>
+          </a:p>
+          <a:p>
+            <a:pPr>
+              <a:spcAft>
+                <a:spcPts val="1000"/>
+              </a:spcAft>
+            </a:pPr>
+            <a:r>
+              <a:rPr sz="1800" b="0">
+                <a:solidFill>
+                  <a:srgbClr val="334155"/>
+                </a:solidFill>
+                <a:latin typeface="Calibri"/>
+              </a:rPr>
+              <a:t>•  realized_stay_share: 0.7248</a:t>
+            </a:r>
+          </a:p>
+          <a:p>
+            <a:pPr>
+              <a:spcAft>
+                <a:spcPts val="1000"/>
+              </a:spcAft>
+            </a:pPr>
+            <a:r>
+              <a:rPr sz="1800" b="0">
+                <a:solidFill>
+                  <a:srgbClr val="334155"/>
+                </a:solidFill>
+                <a:latin typeface="Calibri"/>
+              </a:rPr>
+              <a:t>•  Data dictionary: see docs/CASE_STUDY.md</a:t>
+            </a:r>
+          </a:p>
         </p:txBody>
       </p:sp>
     </p:spTree>
@@ -4371,114 +4839,107 @@
                 </a:solidFill>
                 <a:latin typeface="Calibri"/>
               </a:rPr>
-              <a:t>5) Key Findings</a:t>
-            </a:r>
-          </a:p>
-        </p:txBody>
-      </p:sp>
-      <p:sp>
-        <p:nvSpPr>
-          <p:cNvPr id="5" name="TextBox 4"/>
-          <p:cNvSpPr txBox="1"/>
+              <a:t>4) Data Overview — charts</a:t>
+            </a:r>
+          </a:p>
+        </p:txBody>
+      </p:sp>
+      <p:pic>
+        <p:nvPicPr>
+          <p:cNvPr id="5" name="Picture 4" descr="01_hotel_cancellations.png"/>
+          <p:cNvPicPr>
+            <a:picLocks noChangeAspect="1"/>
+          </p:cNvPicPr>
           <p:nvPr/>
-        </p:nvSpPr>
-        <p:spPr>
-          <a:xfrm>
-            <a:off x="640080" y="1051560"/>
-            <a:ext cx="10972800" cy="4937760"/>
+        </p:nvPicPr>
+        <p:blipFill>
+          <a:blip r:embed="rId2"/>
+          <a:stretch>
+            <a:fillRect/>
+          </a:stretch>
+        </p:blipFill>
+        <p:spPr>
+          <a:xfrm>
+            <a:off x="502920" y="1051560"/>
+            <a:ext cx="5394960" cy="2862115"/>
           </a:xfrm>
           <a:prstGeom prst="rect">
             <a:avLst/>
           </a:prstGeom>
-          <a:noFill/>
-        </p:spPr>
-        <p:txBody>
-          <a:bodyPr wrap="square">
-            <a:spAutoFit/>
-          </a:bodyPr>
-          <a:lstStyle/>
-          <a:p>
-            <a:pPr>
-              <a:spcAft>
-                <a:spcPts val="1000"/>
-              </a:spcAft>
-            </a:pPr>
-            <a:r>
-              <a:rPr sz="1800" b="0">
-                <a:solidFill>
-                  <a:srgbClr val="334155"/>
-                </a:solidFill>
-                <a:latin typeface="Calibri"/>
-              </a:rPr>
-              <a:t>•  Overall cancellation rate is 27.5% after cleaning.</a:t>
-            </a:r>
-          </a:p>
-          <a:p>
-            <a:pPr>
-              <a:spcAft>
-                <a:spcPts val="1000"/>
-              </a:spcAft>
-            </a:pPr>
-            <a:r>
-              <a:rPr sz="1800" b="0">
-                <a:solidFill>
-                  <a:srgbClr val="334155"/>
-                </a:solidFill>
-                <a:latin typeface="Calibri"/>
-              </a:rPr>
-              <a:t>•  Guests book about 80 days ahead on average; longer lead times track with more cancellations (r=0.18).</a:t>
-            </a:r>
-          </a:p>
-          <a:p>
-            <a:pPr>
-              <a:spcAft>
-                <a:spcPts val="1000"/>
-              </a:spcAft>
-            </a:pPr>
-            <a:r>
-              <a:rPr sz="1800" b="0">
-                <a:solidFill>
-                  <a:srgbClr val="334155"/>
-                </a:solidFill>
-                <a:latin typeface="Calibri"/>
-              </a:rPr>
-              <a:t>•  August is the busiest arrival month; August leads ADR × stay revenue.</a:t>
-            </a:r>
-          </a:p>
-          <a:p>
-            <a:pPr>
-              <a:spcAft>
-                <a:spcPts val="1000"/>
-              </a:spcAft>
-            </a:pPr>
-            <a:r>
-              <a:rPr sz="1800" b="0">
-                <a:solidFill>
-                  <a:srgbClr val="334155"/>
-                </a:solidFill>
-                <a:latin typeface="Calibri"/>
-              </a:rPr>
-              <a:t>•  PRT and other top origin markets dominate volume; PRT is the single largest country.</a:t>
-            </a:r>
-          </a:p>
-          <a:p>
-            <a:pPr>
-              <a:spcAft>
-                <a:spcPts val="1000"/>
-              </a:spcAft>
-            </a:pPr>
-            <a:r>
-              <a:rPr sz="1800" b="0">
-                <a:solidFill>
-                  <a:srgbClr val="334155"/>
-                </a:solidFill>
-                <a:latin typeface="Calibri"/>
-              </a:rPr>
-              <a:t>•  A logistic model using lead time, deposit, segment, and requests reaches AUC 0.77 on a hold-out set.</a:t>
-            </a:r>
-          </a:p>
-        </p:txBody>
-      </p:sp>
+        </p:spPr>
+      </p:pic>
+      <p:pic>
+        <p:nvPicPr>
+          <p:cNvPr id="6" name="Picture 5" descr="02_arrivals_by_month.png"/>
+          <p:cNvPicPr>
+            <a:picLocks noChangeAspect="1"/>
+          </p:cNvPicPr>
+          <p:nvPr/>
+        </p:nvPicPr>
+        <p:blipFill>
+          <a:blip r:embed="rId3"/>
+          <a:stretch>
+            <a:fillRect/>
+          </a:stretch>
+        </p:blipFill>
+        <p:spPr>
+          <a:xfrm>
+            <a:off x="6263640" y="1051560"/>
+            <a:ext cx="5394960" cy="2616440"/>
+          </a:xfrm>
+          <a:prstGeom prst="rect">
+            <a:avLst/>
+          </a:prstGeom>
+        </p:spPr>
+      </p:pic>
+      <p:pic>
+        <p:nvPicPr>
+          <p:cNvPr id="7" name="Picture 6" descr="03_lead_time_cancel.png"/>
+          <p:cNvPicPr>
+            <a:picLocks noChangeAspect="1"/>
+          </p:cNvPicPr>
+          <p:nvPr/>
+        </p:nvPicPr>
+        <p:blipFill>
+          <a:blip r:embed="rId4"/>
+          <a:stretch>
+            <a:fillRect/>
+          </a:stretch>
+        </p:blipFill>
+        <p:spPr>
+          <a:xfrm>
+            <a:off x="502920" y="3703320"/>
+            <a:ext cx="5394960" cy="2863812"/>
+          </a:xfrm>
+          <a:prstGeom prst="rect">
+            <a:avLst/>
+          </a:prstGeom>
+        </p:spPr>
+      </p:pic>
+      <p:pic>
+        <p:nvPicPr>
+          <p:cNvPr id="8" name="Picture 7" descr="04_adr_by_year.png"/>
+          <p:cNvPicPr>
+            <a:picLocks noChangeAspect="1"/>
+          </p:cNvPicPr>
+          <p:nvPr/>
+        </p:nvPicPr>
+        <p:blipFill>
+          <a:blip r:embed="rId5"/>
+          <a:stretch>
+            <a:fillRect/>
+          </a:stretch>
+        </p:blipFill>
+        <p:spPr>
+          <a:xfrm>
+            <a:off x="6263640" y="3703320"/>
+            <a:ext cx="5394960" cy="2873442"/>
+          </a:xfrm>
+          <a:prstGeom prst="rect">
+            <a:avLst/>
+          </a:prstGeom>
+        </p:spPr>
+      </p:pic>
     </p:spTree>
   </p:cSld>
   <p:clrMapOvr>
@@ -4612,7 +5073,7 @@
                 </a:solidFill>
                 <a:latin typeface="Calibri"/>
               </a:rPr>
-              <a:t>6) Limitations</a:t>
+              <a:t>5) Key Findings</a:t>
             </a:r>
           </a:p>
         </p:txBody>
@@ -4651,7 +5112,7 @@
                 </a:solidFill>
                 <a:latin typeface="Calibri"/>
               </a:rPr>
-              <a:t>•  The public dataset covers two hotels in Portugal, not a global brand.</a:t>
+              <a:t>•  Overall cancellation rate is 27.5% after cleaning.</a:t>
             </a:r>
           </a:p>
           <a:p>
@@ -4667,7 +5128,7 @@
                 </a:solidFill>
                 <a:latin typeface="Calibri"/>
               </a:rPr>
-              <a:t>•  ADR is not full P&amp;L; extras, commissions, and costs are missing.</a:t>
+              <a:t>•  Guests book about 80 days ahead on average; longer lead times track with more cancellations (r=0.18).</a:t>
             </a:r>
           </a:p>
           <a:p>
@@ -4683,7 +5144,7 @@
                 </a:solidFill>
                 <a:latin typeface="Calibri"/>
               </a:rPr>
-              <a:t>•  Company and agent IDs are anonymized and heavily missing.</a:t>
+              <a:t>•  August is the busiest arrival month; August leads ADR × stay revenue.</a:t>
             </a:r>
           </a:p>
           <a:p>
@@ -4699,7 +5160,7 @@
                 </a:solidFill>
                 <a:latin typeface="Calibri"/>
               </a:rPr>
-              <a:t>•  Guest satisfaction is proxied by requests and repeats, not survey scores.</a:t>
+              <a:t>•  PRT and other top origin markets dominate volume; PRT is the single largest country.</a:t>
             </a:r>
           </a:p>
           <a:p>
@@ -4715,7 +5176,7 @@
                 </a:solidFill>
                 <a:latin typeface="Calibri"/>
               </a:rPr>
-              <a:t>•  Cancellation model is explanatory, not a production overbooking engine.</a:t>
+              <a:t>•  A logistic model using lead time, deposit, segment, and requests reaches AUC 0.77 on a hold-out set.</a:t>
             </a:r>
           </a:p>
         </p:txBody>
@@ -4853,50 +5314,59 @@
                 </a:solidFill>
                 <a:latin typeface="Calibri"/>
               </a:rPr>
-              <a:t>7) Conclusion</a:t>
-            </a:r>
-          </a:p>
-        </p:txBody>
-      </p:sp>
-      <p:sp>
-        <p:nvSpPr>
-          <p:cNvPr id="5" name="TextBox 4"/>
-          <p:cNvSpPr txBox="1"/>
+              <a:t>5) Key Findings — charts</a:t>
+            </a:r>
+          </a:p>
+        </p:txBody>
+      </p:sp>
+      <p:pic>
+        <p:nvPicPr>
+          <p:cNvPr id="5" name="Picture 4" descr="05_adr_by_segment.png"/>
+          <p:cNvPicPr>
+            <a:picLocks noChangeAspect="1"/>
+          </p:cNvPicPr>
           <p:nvPr/>
-        </p:nvSpPr>
-        <p:spPr>
-          <a:xfrm>
-            <a:off x="640080" y="1051560"/>
-            <a:ext cx="10972800" cy="4937760"/>
+        </p:nvPicPr>
+        <p:blipFill>
+          <a:blip r:embed="rId2"/>
+          <a:stretch>
+            <a:fillRect/>
+          </a:stretch>
+        </p:blipFill>
+        <p:spPr>
+          <a:xfrm>
+            <a:off x="502920" y="1051560"/>
+            <a:ext cx="5394960" cy="2865733"/>
           </a:xfrm>
           <a:prstGeom prst="rect">
             <a:avLst/>
           </a:prstGeom>
-          <a:noFill/>
-        </p:spPr>
-        <p:txBody>
-          <a:bodyPr wrap="square">
-            <a:spAutoFit/>
-          </a:bodyPr>
-          <a:lstStyle/>
-          <a:p>
-            <a:pPr>
-              <a:spcAft>
-                <a:spcPts val="1000"/>
-              </a:spcAft>
-            </a:pPr>
-            <a:r>
-              <a:rPr sz="1800" b="0">
-                <a:solidFill>
-                  <a:srgbClr val="334155"/>
-                </a:solidFill>
-                <a:latin typeface="Calibri"/>
-              </a:rPr>
-              <a:t>•  Demand is seasonal and channel-dependent. City vs resort mix, non-refundable deposits, and long lead times are the practical levers for cancellation control, while ADR and segment mix drive revenue planning.</a:t>
-            </a:r>
-          </a:p>
-        </p:txBody>
-      </p:sp>
+        </p:spPr>
+      </p:pic>
+      <p:pic>
+        <p:nvPicPr>
+          <p:cNvPr id="6" name="Picture 5" descr="06_lead_time_segment.png"/>
+          <p:cNvPicPr>
+            <a:picLocks noChangeAspect="1"/>
+          </p:cNvPicPr>
+          <p:nvPr/>
+        </p:nvPicPr>
+        <p:blipFill>
+          <a:blip r:embed="rId3"/>
+          <a:stretch>
+            <a:fillRect/>
+          </a:stretch>
+        </p:blipFill>
+        <p:spPr>
+          <a:xfrm>
+            <a:off x="6263640" y="1051560"/>
+            <a:ext cx="5394960" cy="2860197"/>
+          </a:xfrm>
+          <a:prstGeom prst="rect">
+            <a:avLst/>
+          </a:prstGeom>
+        </p:spPr>
+      </p:pic>
     </p:spTree>
   </p:cSld>
   <p:clrMapOvr>
@@ -5030,7 +5500,7 @@
                 </a:solidFill>
                 <a:latin typeface="Calibri"/>
               </a:rPr>
-              <a:t>8) Recommendations</a:t>
+              <a:t>6) Limitations</a:t>
             </a:r>
           </a:p>
         </p:txBody>
@@ -5069,7 +5539,7 @@
                 </a:solidFill>
                 <a:latin typeface="Calibri"/>
               </a:rPr>
-              <a:t>•  Tighten deposit or reminder policies on long-lead leisure bookings with high cancel risk.</a:t>
+              <a:t>•  The public dataset covers two hotels in Portugal, not a global brand.</a:t>
             </a:r>
           </a:p>
           <a:p>
@@ -5085,7 +5555,7 @@
                 </a:solidFill>
                 <a:latin typeface="Calibri"/>
               </a:rPr>
-              <a:t>•  Staff and price for the summer/peak-month wave rather than a flat annual plan.</a:t>
+              <a:t>•  ADR is not full P&amp;L; extras, commissions, and costs are missing.</a:t>
             </a:r>
           </a:p>
           <a:p>
@@ -5101,7 +5571,7 @@
                 </a:solidFill>
                 <a:latin typeface="Calibri"/>
               </a:rPr>
-              <a:t>•  Protect relationships with TA/TO and Direct channels that carry volume.</a:t>
+              <a:t>•  Company and agent IDs are anonymized and heavily missing.</a:t>
             </a:r>
           </a:p>
           <a:p>
@@ -5117,7 +5587,7 @@
                 </a:solidFill>
                 <a:latin typeface="Calibri"/>
               </a:rPr>
-              <a:t>•  Use parking and special-request data to design upsell packages, not only room rate.</a:t>
+              <a:t>•  Guest satisfaction is proxied by requests and repeats, not survey scores.</a:t>
             </a:r>
           </a:p>
           <a:p>
@@ -5133,7 +5603,7 @@
                 </a:solidFill>
                 <a:latin typeface="Calibri"/>
               </a:rPr>
-              <a:t>•  Build a repeat-guest offer; loyalty stays look different from first-time transient stays.</a:t>
+              <a:t>•  Cancellation model is explanatory, not a production overbooking engine.</a:t>
             </a:r>
           </a:p>
         </p:txBody>

</xml_diff>